<commit_message>
add audio to ppt
</commit_message>
<xml_diff>
--- a/Agentic Systems/6- PPTX Builder Agent/lecture.pptx
+++ b/Agentic Systems/6- PPTX Builder Agent/lecture.pptx
@@ -3157,7 +3157,7 @@
               </a:defRPr>
             </a:pPr>
             <a:r>
-              <a:t>Introduction</a:t>
+              <a:t>Introduction to Generative Artificial Intelligence (GenAI): Emergence and Significance</a:t>
             </a:r>
           </a:p>
         </p:txBody>
@@ -3195,7 +3195,7 @@
               </a:defRPr>
             </a:pPr>
             <a:r>
-              <a:t>Overview and context of the topic about Introduction</a:t>
+              <a:t>By the end of this study, learners should understand the emergence and significance of Generative Ar</a:t>
             </a:r>
           </a:p>
         </p:txBody>
@@ -3235,11 +3235,66 @@
           </a:fontRef>
         </p:style>
       </p:cxnSp>
+      <p:pic>
+        <p:nvPicPr>
+          <p:cNvPr id="6" name="slide_01_audio.wav">
+            <a:hlinkClick r:id="" action="ppaction://media"/>
+          </p:cNvPr>
+          <p:cNvPicPr>
+            <a:picLocks noChangeAspect="1"/>
+          </p:cNvPicPr>
+          <p:nvPr>
+            <a:videoFile r:link="rId4"/>
+            <p:extLst>
+              <p:ext uri="{DAA4B4D4-6D71-4841-9C94-3DE7FCFB9230}">
+                <p14:media xmlns:p14="http://schemas.microsoft.com/office/powerpoint/2010/main" r:embed="rId3"/>
+              </p:ext>
+            </p:extLst>
+          </p:nvPr>
+        </p:nvPicPr>
+        <p:blipFill>
+          <a:blip r:embed="rId5"/>
+          <a:stretch>
+            <a:fillRect/>
+          </a:stretch>
+        </p:blipFill>
+        <p:spPr>
+          <a:xfrm>
+            <a:off x="8503920" y="4503420"/>
+            <a:ext cx="457200" cy="457200"/>
+          </a:xfrm>
+          <a:prstGeom prst="rect">
+            <a:avLst/>
+          </a:prstGeom>
+        </p:spPr>
+      </p:pic>
     </p:spTree>
   </p:cSld>
   <p:clrMapOvr>
     <a:masterClrMapping/>
   </p:clrMapOvr>
+  <p:timing>
+    <p:tnLst>
+      <p:par>
+        <p:cTn id="1" dur="indefinite" restart="never" nodeType="tmRoot">
+          <p:childTnLst>
+            <p:video>
+              <p:cMediaNode vol="80000">
+                <p:cTn id="2" fill="hold" display="0">
+                  <p:stCondLst>
+                    <p:cond delay="indefinite"/>
+                  </p:stCondLst>
+                </p:cTn>
+                <p:tgtEl>
+                  <p:spTgt spid="6"/>
+                </p:tgtEl>
+              </p:cMediaNode>
+            </p:video>
+          </p:childTnLst>
+        </p:cTn>
+      </p:par>
+    </p:tnLst>
+  </p:timing>
 </p:sld>
 </file>
 
@@ -3336,7 +3391,7 @@
               </a:defRPr>
             </a:pPr>
             <a:r>
-              <a:t>Best Practices</a:t>
+              <a:t>Case Study: Image Generation with Midjourney – Techniques and Creative Applications</a:t>
             </a:r>
           </a:p>
         </p:txBody>
@@ -3374,7 +3429,7 @@
               </a:defRPr>
             </a:pPr>
             <a:r>
-              <a:t>Recommended practices and common pitfalls. What are these new-era AI technologies? How do they function? What principles</a:t>
+              <a:t>By studying this material, learners should understand the role and capabilities of image-based generative AI models like</a:t>
             </a:r>
           </a:p>
         </p:txBody>
@@ -3454,7 +3509,7 @@
               </a:defRPr>
             </a:pPr>
             <a:r>
-              <a:t>What are these new-era AI technolog</a:t>
+              <a:t>Generative AI models and their vari</a:t>
             </a:r>
           </a:p>
         </p:txBody>
@@ -3534,7 +3589,7 @@
               </a:defRPr>
             </a:pPr>
             <a:r>
-              <a:t>produce a completion conditioned on</a:t>
+              <a:t>Supervised learning as a foundation</a:t>
             </a:r>
           </a:p>
         </p:txBody>
@@ -3614,7 +3669,7 @@
               </a:defRPr>
             </a:pPr>
             <a:r>
-              <a:t>We start with the most well-underst</a:t>
+              <a:t>The limitations of pre-deep-learnin</a:t>
             </a:r>
           </a:p>
         </p:txBody>
@@ -3694,7 +3749,7 @@
               </a:defRPr>
             </a:pPr>
             <a:r>
-              <a:t>What are these new-era AI technologies? How do they function? What principles do they operate o</a:t>
+              <a:t>While large language models (LLMs) dominate the current landscape of generative AI due to their</a:t>
             </a:r>
           </a:p>
         </p:txBody>
@@ -3774,7 +3829,7 @@
               </a:defRPr>
             </a:pPr>
             <a:r>
-              <a:t>The report will also tease out how this understanding foundationally informs the best uses (and</a:t>
+              <a:t>Supervised learning aims to create prediction rules that generalize well to unseen data by leve</a:t>
             </a:r>
           </a:p>
         </p:txBody>
@@ -3854,7 +3909,7 @@
               </a:defRPr>
             </a:pPr>
             <a:r>
-              <a:t>produce a completion conditioned on the initial set of words</a:t>
+              <a:t>Before the advent of deep learning, supervised algorithms struggled with visual and auditory da</a:t>
             </a:r>
           </a:p>
         </p:txBody>
@@ -3934,7 +3989,7 @@
               </a:defRPr>
             </a:pPr>
             <a:r>
-              <a:t>In this way, the initial context window, termed prompt, matters crucially to the produced compl</a:t>
+              <a:t>Deep learning transformed machine learning by automating representation learning through multi-</a:t>
             </a:r>
           </a:p>
         </p:txBody>
@@ -4014,7 +4069,7 @@
               </a:defRPr>
             </a:pPr>
             <a:r>
-              <a:t>One hallmark of modern language models is that they keep track of the initial prompt even when </a:t>
+              <a:t>Generative AI models like Midjourney introduce randomness through stochastic sampling, allowing</a:t>
             </a:r>
           </a:p>
         </p:txBody>
@@ -4193,7 +4248,7 @@
               </a:defRPr>
             </a:pPr>
             <a:r>
-              <a:t>Limitations and Challenges</a:t>
+              <a:t>Case Study: Code Generation with GitHub Copilot – Transforming Software Development Workflows</a:t>
             </a:r>
           </a:p>
         </p:txBody>
@@ -4231,7 +4286,7 @@
               </a:defRPr>
             </a:pPr>
             <a:r>
-              <a:t>Constraints, limitations, and solutions. Generative artificial intelligence (GenAI) tools are an emerging class of new-a</a:t>
+              <a:t>By studying this material, learners should understand how GitHub Copilot exemplifies the practical application of code-b</a:t>
             </a:r>
           </a:p>
         </p:txBody>
@@ -4311,7 +4366,7 @@
               </a:defRPr>
             </a:pPr>
             <a:r>
-              <a:t>Generative artificial intelligence </a:t>
+              <a:t>Generative Artificial Intelligence </a:t>
             </a:r>
           </a:p>
         </p:txBody>
@@ -4391,7 +4446,7 @@
               </a:defRPr>
             </a:pPr>
             <a:r>
-              <a:t>This rapid progress has led many to</a:t>
+              <a:t>Large Language Models (LLMs) that g</a:t>
             </a:r>
           </a:p>
         </p:txBody>
@@ -4471,7 +4526,7 @@
               </a:defRPr>
             </a:pPr>
             <a:r>
-              <a:t>What are these new-era AI technolog</a:t>
+              <a:t>Supervised learning as a machine le</a:t>
             </a:r>
           </a:p>
         </p:txBody>
@@ -4551,7 +4606,7 @@
               </a:defRPr>
             </a:pPr>
             <a:r>
-              <a:t>Generative artificial intelligence (GenAI) tools are an emerging class of new-age artificial in</a:t>
+              <a:t>GitHub Copilot demonstrates the successful commercial deployment of code-based generative AI mo</a:t>
             </a:r>
           </a:p>
         </p:txBody>
@@ -4631,7 +4686,7 @@
               </a:defRPr>
             </a:pPr>
             <a:r>
-              <a:t>Recent advances in machine learning (ML), massive datasets, and substantial increases in comput</a:t>
+              <a:t>While generative AI models span multiple modalities, including audio, video, and images, this r</a:t>
             </a:r>
           </a:p>
         </p:txBody>
@@ -4711,7 +4766,7 @@
               </a:defRPr>
             </a:pPr>
             <a:r>
-              <a:t>This rapid progress has led many to to believe that the metamorphosis of these technologies 2fr</a:t>
+              <a:t>The core functionality of a language model lies in its ability to predict the next word in a se</a:t>
             </a:r>
           </a:p>
         </p:txBody>
@@ -4791,7 +4846,7 @@
               </a:defRPr>
             </a:pPr>
             <a:r>
-              <a:t>It took OpenAI's ChatGPT, a conversational web app based on a generative (multimodal) language </a:t>
+              <a:t>Generative AI tools have achieved human-level performance on academic and professional benchmar</a:t>
             </a:r>
           </a:p>
         </p:txBody>
@@ -4871,7 +4926,7 @@
               </a:defRPr>
             </a:pPr>
             <a:r>
-              <a:t>On the business side, the Economist reports that the number of jobs mentioning AI-related skill</a:t>
+              <a:t>Introducing randomness by sampling from the probability distribution of next-word predictions—r</a:t>
             </a:r>
           </a:p>
         </p:txBody>
@@ -5050,7 +5105,7 @@
               </a:defRPr>
             </a:pPr>
             <a:r>
-              <a:t>Future Developments</a:t>
+              <a:t>Ethical, Societal, and Operational Implications of Deploying GenAI in Real-World Scenarios</a:t>
             </a:r>
           </a:p>
         </p:txBody>
@@ -5088,7 +5143,7 @@
               </a:defRPr>
             </a:pPr>
             <a:r>
-              <a:t>Emerging trends and research directions. What are these new-era AI technologies? How do they function? What principles d</a:t>
+              <a:t>By studying this material, learners should understand the foundational principles and real-world implications of deployi</a:t>
             </a:r>
           </a:p>
         </p:txBody>
@@ -5168,7 +5223,7 @@
               </a:defRPr>
             </a:pPr>
             <a:r>
-              <a:t>What are these new-era AI technolog</a:t>
+              <a:t>Generative Artificial Intelligence </a:t>
             </a:r>
           </a:p>
         </p:txBody>
@@ -5248,7 +5303,7 @@
               </a:defRPr>
             </a:pPr>
             <a:r>
-              <a:t>We address these questions indirect</a:t>
+              <a:t>Large Language Models (LLMs) as a d</a:t>
             </a:r>
           </a:p>
         </p:txBody>
@@ -5328,7 +5383,7 @@
               </a:defRPr>
             </a:pPr>
             <a:r>
-              <a:t>Key aspect of Future Developments</a:t>
+              <a:t>Prompt engineering as the practice </a:t>
             </a:r>
           </a:p>
         </p:txBody>
@@ -5408,7 +5463,7 @@
               </a:defRPr>
             </a:pPr>
             <a:r>
-              <a:t>What are these new-era AI technologies? How do they function? What principles do they operate o</a:t>
+              <a:t>Generative AI tools have achieved human-level performance on academic and professional benchmar</a:t>
             </a:r>
           </a:p>
         </p:txBody>
@@ -5488,7 +5543,7 @@
               </a:defRPr>
             </a:pPr>
             <a:r>
-              <a:t>The report will also tease out how this understanding foundationally informs the best uses (and</a:t>
+              <a:t>The rapid adoption of GenAI is evident in its exponential user growth—OpenAI’s ChatGPT reached </a:t>
             </a:r>
           </a:p>
         </p:txBody>
@@ -5568,7 +5623,7 @@
               </a:defRPr>
             </a:pPr>
             <a:r>
-              <a:t>We address these questions indirectly in the present section by taking a tour of the essential </a:t>
+              <a:t>While GenAI encompasses a broad range of modalities, including image and code generation, large</a:t>
             </a:r>
           </a:p>
         </p:txBody>
@@ -5648,7 +5703,7 @@
               </a:defRPr>
             </a:pPr>
             <a:r>
-              <a:t>Important aspect of Future Developments</a:t>
+              <a:t>The deployment of GenAI in real-world scenarios introduces significant ethical, societal, and o</a:t>
             </a:r>
           </a:p>
         </p:txBody>
@@ -5728,7 +5783,7 @@
               </a:defRPr>
             </a:pPr>
             <a:r>
-              <a:t>Important aspect of Future Developments</a:t>
+              <a:t>The speculative nature of GenAI’s long-term impact reflects its position in the early stages of</a:t>
             </a:r>
           </a:p>
         </p:txBody>
@@ -5923,7 +5978,7 @@
               </a:defRPr>
             </a:pPr>
             <a:r>
-              <a:t>Conclusion</a:t>
+              <a:t>Synthesis and Key Takeaways: The Future Trajectory and Research Directions in GenAI</a:t>
             </a:r>
           </a:p>
         </p:txBody>
@@ -5999,7 +6054,7 @@
               </a:defRPr>
             </a:pPr>
             <a:r>
-              <a:t>Karan Singh, Assistant Professor of Operations Research</a:t>
+              <a:t>Generative AI tools have achieved human-level performance on academic and professional ben</a:t>
             </a:r>
           </a:p>
         </p:txBody>
@@ -6075,7 +6130,7 @@
               </a:defRPr>
             </a:pPr>
             <a:r>
-              <a:t>Generative artificial intelligence (GenAI) tools are an emerging class of new-age artifici</a:t>
+              <a:t>The adoption of GenAI has been extraordinarily swift, with platforms like OpenAI’s ChatGPT</a:t>
             </a:r>
           </a:p>
         </p:txBody>
@@ -6151,7 +6206,7 @@
               </a:defRPr>
             </a:pPr>
             <a:r>
-              <a:t>Recent advances in machine learning (ML), massive datasets, and substantial increases in c</a:t>
+              <a:t>The economic and operational impact of GenAI is already substantial, with the number of jo</a:t>
             </a:r>
           </a:p>
         </p:txBody>
@@ -6227,7 +6282,7 @@
               </a:defRPr>
             </a:pPr>
             <a:r>
-              <a:t>This rapid progress has led many to to believe that the metamorphosis of these technologie</a:t>
+              <a:t>While GenAI encompasses a broad range of modalities, including images, audio, and code, la</a:t>
             </a:r>
           </a:p>
         </p:txBody>
@@ -6371,7 +6426,7 @@
               </a:defRPr>
             </a:pPr>
             <a:r>
-              <a:t>Fundamentals - Part 1</a:t>
+              <a:t>Defining Generative AI: Core Concepts and Distinctions from Traditional Machine Learning</a:t>
             </a:r>
           </a:p>
         </p:txBody>
@@ -6409,7 +6464,7 @@
               </a:defRPr>
             </a:pPr>
             <a:r>
-              <a:t>Core concepts and foundational terminology. While generative AI models come in many different shapes, utilizing varied s</a:t>
+              <a:t>By studying this material, learners should master the fundamental distinctions between generative AI and traditional mac</a:t>
             </a:r>
           </a:p>
         </p:txBody>
@@ -6489,7 +6544,7 @@
               </a:defRPr>
             </a:pPr>
             <a:r>
-              <a:t>While generative AI models come in </a:t>
+              <a:t>Generative artificial intelligence </a:t>
             </a:r>
           </a:p>
         </p:txBody>
@@ -6569,7 +6624,7 @@
               </a:defRPr>
             </a:pPr>
             <a:r>
-              <a:t>perspective in getting varied respo</a:t>
+              <a:t>Supervised learning as a subset of </a:t>
             </a:r>
           </a:p>
         </p:txBody>
@@ -6649,7 +6704,7 @@
               </a:defRPr>
             </a:pPr>
             <a:r>
-              <a:t>assumption that seen data must be r</a:t>
+              <a:t>The centrality of predictive perfor</a:t>
             </a:r>
           </a:p>
         </p:txBody>
@@ -6729,7 +6784,7 @@
               </a:defRPr>
             </a:pPr>
             <a:r>
-              <a:t>While generative AI models come in many different shapes, utilizing varied statistical and comp</a:t>
+              <a:t>Generative AI tools have achieved human-level performance on academic and professional benchmar</a:t>
             </a:r>
           </a:p>
         </p:txBody>
@@ -6809,7 +6864,7 @@
               </a:defRPr>
             </a:pPr>
             <a:r>
-              <a:t>This choice is partly due to the substantial lead LLMs have in driving the overall usage of gen</a:t>
+              <a:t>Traditional supervised learning relies on labeled examples to train prediction rules, such as l</a:t>
             </a:r>
           </a:p>
         </p:txBody>
@@ -6889,7 +6944,7 @@
               </a:defRPr>
             </a:pPr>
             <a:r>
-              <a:t>That said, image- and code-based GenAI models have already witnessed successful commercial prod</a:t>
+              <a:t>The simplicity of focusing solely on predictive performance, rather than causality or statistic</a:t>
             </a:r>
           </a:p>
         </p:txBody>
@@ -6969,7 +7024,7 @@
               </a:defRPr>
             </a:pPr>
             <a:r>
-              <a:t>perspective in getting varied responses</a:t>
+              <a:t>The rapid adoption of generative AI, exemplified by OpenAI's ChatGPT reaching one million users</a:t>
             </a:r>
           </a:p>
         </p:txBody>
@@ -7049,7 +7104,7 @@
               </a:defRPr>
             </a:pPr>
             <a:r>
-              <a:t>From the deployer's perspective, this optionally allows the model to gather user feedback regar</a:t>
+              <a:t>While generative AI encompasses models for various modalities, large language models (LLMs) hav</a:t>
             </a:r>
           </a:p>
         </p:txBody>
@@ -7127,11 +7182,66 @@
           </a:p>
         </p:txBody>
       </p:sp>
+      <p:pic>
+        <p:nvPicPr>
+          <p:cNvPr id="23" name="slide_02_audio.wav">
+            <a:hlinkClick r:id="" action="ppaction://media"/>
+          </p:cNvPr>
+          <p:cNvPicPr>
+            <a:picLocks noChangeAspect="1"/>
+          </p:cNvPicPr>
+          <p:nvPr>
+            <a:videoFile r:link="rId3"/>
+            <p:extLst>
+              <p:ext uri="{DAA4B4D4-6D71-4841-9C94-3DE7FCFB9230}">
+                <p14:media xmlns:p14="http://schemas.microsoft.com/office/powerpoint/2010/main" r:embed="rId2"/>
+              </p:ext>
+            </p:extLst>
+          </p:nvPr>
+        </p:nvPicPr>
+        <p:blipFill>
+          <a:blip r:embed="rId4"/>
+          <a:stretch>
+            <a:fillRect/>
+          </a:stretch>
+        </p:blipFill>
+        <p:spPr>
+          <a:xfrm>
+            <a:off x="8503920" y="4503420"/>
+            <a:ext cx="457200" cy="457200"/>
+          </a:xfrm>
+          <a:prstGeom prst="rect">
+            <a:avLst/>
+          </a:prstGeom>
+        </p:spPr>
+      </p:pic>
     </p:spTree>
   </p:cSld>
   <p:clrMapOvr>
     <a:masterClrMapping/>
   </p:clrMapOvr>
+  <p:timing>
+    <p:tnLst>
+      <p:par>
+        <p:cTn id="1" dur="indefinite" restart="never" nodeType="tmRoot">
+          <p:childTnLst>
+            <p:video>
+              <p:cMediaNode vol="80000">
+                <p:cTn id="2" fill="hold" display="0">
+                  <p:stCondLst>
+                    <p:cond delay="indefinite"/>
+                  </p:stCondLst>
+                </p:cTn>
+                <p:tgtEl>
+                  <p:spTgt spid="23"/>
+                </p:tgtEl>
+              </p:cMediaNode>
+            </p:video>
+          </p:childTnLst>
+        </p:cTn>
+      </p:par>
+    </p:tnLst>
+  </p:timing>
 </p:sld>
 </file>
 
@@ -7228,7 +7338,7 @@
               </a:defRPr>
             </a:pPr>
             <a:r>
-              <a:t>Fundamentals - Part 2</a:t>
+              <a:t>Taxonomy of GenAI-Related Disciplines: A Comprehensive Classification Framework</a:t>
             </a:r>
           </a:p>
         </p:txBody>
@@ -7266,7 +7376,7 @@
               </a:defRPr>
             </a:pPr>
             <a:r>
-              <a:t>Essential principles and frameworks. While generative AI models come in many different shapes, utilizing varied statisti</a:t>
+              <a:t>By studying this material, learners should master the foundational principles and practical applications of key discipli</a:t>
             </a:r>
           </a:p>
         </p:txBody>
@@ -7346,7 +7456,7 @@
               </a:defRPr>
             </a:pPr>
             <a:r>
-              <a:t>While generative AI models come in </a:t>
+              <a:t>The primacy of prediction as the ce</a:t>
             </a:r>
           </a:p>
         </p:txBody>
@@ -7426,7 +7536,7 @@
               </a:defRPr>
             </a:pPr>
             <a:r>
-              <a:t>perspective in getting varied respo</a:t>
+              <a:t>The distributional hypothesis in co</a:t>
             </a:r>
           </a:p>
         </p:txBody>
@@ -7506,7 +7616,7 @@
               </a:defRPr>
             </a:pPr>
             <a:r>
-              <a:t>assumption that seen data must be r</a:t>
+              <a:t>Contrastive learning, an unsupervis</a:t>
             </a:r>
           </a:p>
         </p:txBody>
@@ -7586,7 +7696,7 @@
               </a:defRPr>
             </a:pPr>
             <a:r>
-              <a:t>While generative AI models come in many different shapes, utilizing varied statistical and comp</a:t>
+              <a:t>In machine learning, the success of a prediction rule is measured by its ability to make reason</a:t>
             </a:r>
           </a:p>
         </p:txBody>
@@ -7666,7 +7776,7 @@
               </a:defRPr>
             </a:pPr>
             <a:r>
-              <a:t>This choice is partly due to the substantial lead LLMs have in driving the overall usage of gen</a:t>
+              <a:t>The distributional hypothesis underpins many modern natural language processing techniques, as </a:t>
             </a:r>
           </a:p>
         </p:txBody>
@@ -7746,7 +7856,7 @@
               </a:defRPr>
             </a:pPr>
             <a:r>
-              <a:t>That said, image- and code-based GenAI models have already witnessed successful commercial prod</a:t>
+              <a:t>Contrastive learning leverages unlabeled data to create pretext tasks, such as distinguishing b</a:t>
             </a:r>
           </a:p>
         </p:txBody>
@@ -7826,7 +7936,7 @@
               </a:defRPr>
             </a:pPr>
             <a:r>
-              <a:t>perspective in getting varied responses</a:t>
+              <a:t>Word2Vec’s vector representations not only capture semantic nuances but also prove invaluable f</a:t>
             </a:r>
           </a:p>
         </p:txBody>
@@ -7906,7 +8016,7 @@
               </a:defRPr>
             </a:pPr>
             <a:r>
-              <a:t>From the deployer's perspective, this optionally allows the model to gather user feedback regar</a:t>
+              <a:t>Machine learning’s strength lies in its ability to reframe a wide array of problems—from predic</a:t>
             </a:r>
           </a:p>
         </p:txBody>
@@ -8085,7 +8195,7 @@
               </a:defRPr>
             </a:pPr>
             <a:r>
-              <a:t>Theory and Background</a:t>
+              <a:t>From Research Demos to Production-Grade Tools: The Evolutionary Trajectory of GenAI Technologies</a:t>
             </a:r>
           </a:p>
         </p:txBody>
@@ -8123,7 +8233,7 @@
               </a:defRPr>
             </a:pPr>
             <a:r>
-              <a:t>Historical context and theoretical foundations. Generative artificial intelligence (GenAI) tools are an emerging class o</a:t>
+              <a:t>By studying this material, learners should understand the transformative journey of generative AI technologies from expe</a:t>
             </a:r>
           </a:p>
         </p:txBody>
@@ -8203,7 +8313,7 @@
               </a:defRPr>
             </a:pPr>
             <a:r>
-              <a:t>Generative artificial intelligence </a:t>
+              <a:t>Generative Artificial Intelligence </a:t>
             </a:r>
           </a:p>
         </p:txBody>
@@ -8283,7 +8393,7 @@
               </a:defRPr>
             </a:pPr>
             <a:r>
-              <a:t>This rapid progress has led many to</a:t>
+              <a:t>Large Language Models (LLMs) that g</a:t>
             </a:r>
           </a:p>
         </p:txBody>
@@ -8363,7 +8473,7 @@
               </a:defRPr>
             </a:pPr>
             <a:r>
-              <a:t>What are these new-era AI technolog</a:t>
+              <a:t>Prompt engineering—the deliberate s</a:t>
             </a:r>
           </a:p>
         </p:txBody>
@@ -8443,7 +8553,7 @@
               </a:defRPr>
             </a:pPr>
             <a:r>
-              <a:t>Generative artificial intelligence (GenAI) tools are an emerging class of new-age artificial in</a:t>
+              <a:t>Generative AI technologies have transitioned rapidly from research demonstrations to accessible</a:t>
             </a:r>
           </a:p>
         </p:txBody>
@@ -8523,7 +8633,7 @@
               </a:defRPr>
             </a:pPr>
             <a:r>
-              <a:t>Recent advances in machine learning (ML), massive datasets, and substantial increases in comput</a:t>
+              <a:t>The economic and operational impact of GenAI is already measurable: the number of job postings </a:t>
             </a:r>
           </a:p>
         </p:txBody>
@@ -8603,7 +8713,7 @@
               </a:defRPr>
             </a:pPr>
             <a:r>
-              <a:t>This rapid progress has led many to to believe that the metamorphosis of these technologies 2fr</a:t>
+              <a:t>While GenAI encompasses models that generate diverse content types—including images, audio, and</a:t>
             </a:r>
           </a:p>
         </p:txBody>
@@ -8683,7 +8793,7 @@
               </a:defRPr>
             </a:pPr>
             <a:r>
-              <a:t>It took OpenAI's ChatGPT, a conversational web app based on a generative (multimodal) language </a:t>
+              <a:t>At their core, LLMs operate on a deceptively simple mechanism: predicting the next word in a se</a:t>
             </a:r>
           </a:p>
         </p:txBody>
@@ -8763,7 +8873,7 @@
               </a:defRPr>
             </a:pPr>
             <a:r>
-              <a:t>On the business side, the Economist reports that the number of jobs mentioning AI-related skill</a:t>
+              <a:t>Successful commercial deployments of GenAI are already evident, such as Adobe’s use of image-ba</a:t>
             </a:r>
           </a:p>
         </p:txBody>
@@ -8942,7 +9052,7 @@
               </a:defRPr>
             </a:pPr>
             <a:r>
-              <a:t>Key Principles</a:t>
+              <a:t>Modalities of GenAI: Text, Audio, Video, and Code Generation Capabilities Explored</a:t>
             </a:r>
           </a:p>
         </p:txBody>
@@ -8980,7 +9090,7 @@
               </a:defRPr>
             </a:pPr>
             <a:r>
-              <a:t>Main principles and guidelines. What are these new-era AI technologies? How do they function? What principles do they op</a:t>
+              <a:t>By studying this material, learners should understand the diverse modalities of Generative AI—particularly text, audio, </a:t>
             </a:r>
           </a:p>
         </p:txBody>
@@ -9060,7 +9170,7 @@
               </a:defRPr>
             </a:pPr>
             <a:r>
-              <a:t>What are these new-era AI technolog</a:t>
+              <a:t>Generative Artificial Intelligence </a:t>
             </a:r>
           </a:p>
         </p:txBody>
@@ -9140,7 +9250,7 @@
               </a:defRPr>
             </a:pPr>
             <a:r>
-              <a:t>Key aspect of Key Principles</a:t>
+              <a:t>Large Language Models (LLMs) as a d</a:t>
             </a:r>
           </a:p>
         </p:txBody>
@@ -9220,7 +9330,7 @@
               </a:defRPr>
             </a:pPr>
             <a:r>
-              <a:t>Key aspect of Key Principles</a:t>
+              <a:t>Prompt engineering, the practice of</a:t>
             </a:r>
           </a:p>
         </p:txBody>
@@ -9300,7 +9410,7 @@
               </a:defRPr>
             </a:pPr>
             <a:r>
-              <a:t>What are these new-era AI technologies? How do they function? What principles do they operate o</a:t>
+              <a:t>Generative AI tools have achieved human-level performance on academic and professional benchmar</a:t>
             </a:r>
           </a:p>
         </p:txBody>
@@ -9380,7 +9490,7 @@
               </a:defRPr>
             </a:pPr>
             <a:r>
-              <a:t>The report will also tease out how this understanding foundationally informs the best uses (and</a:t>
+              <a:t>While GenAI encompasses multiple modalities, large language models (LLMs) dominate usage due to</a:t>
             </a:r>
           </a:p>
         </p:txBody>
@@ -9460,7 +9570,7 @@
               </a:defRPr>
             </a:pPr>
             <a:r>
-              <a:t>Important aspect of Key Principles</a:t>
+              <a:t>Modern language models maintain coherence over large bodies of text by tracking the initial pro</a:t>
             </a:r>
           </a:p>
         </p:txBody>
@@ -9540,7 +9650,7 @@
               </a:defRPr>
             </a:pPr>
             <a:r>
-              <a:t>Important aspect of Key Principles</a:t>
+              <a:t>Supervised learning relies on the assumption that a prediction rule trained on labeled data wil</a:t>
             </a:r>
           </a:p>
         </p:txBody>
@@ -9620,7 +9730,7 @@
               </a:defRPr>
             </a:pPr>
             <a:r>
-              <a:t>Important aspect of Key Principles</a:t>
+              <a:t>Early neural networks like Recurrent Neural Networks (RNNs) introduced memory into text process</a:t>
             </a:r>
           </a:p>
         </p:txBody>
@@ -9799,7 +9909,7 @@
               </a:defRPr>
             </a:pPr>
             <a:r>
-              <a:t>Implementation Methods</a:t>
+              <a:t>Underlying Principles of GenAI: Probabilistic Models and Statistical Foundations</a:t>
             </a:r>
           </a:p>
         </p:txBody>
@@ -9837,7 +9947,7 @@
               </a:defRPr>
             </a:pPr>
             <a:r>
-              <a:t>Practical approaches and methodologies. While word embeddings serve as proof that textual semantic regularities can be a</a:t>
+              <a:t>By studying this material, learners should grasp the foundational principles that distinguish generative AI—particularly</a:t>
             </a:r>
           </a:p>
         </p:txBody>
@@ -9917,7 +10027,7 @@
               </a:defRPr>
             </a:pPr>
             <a:r>
-              <a:t>While word embeddings serve as proo</a:t>
+              <a:t>Large language models (LLMs) as con</a:t>
             </a:r>
           </a:p>
         </p:txBody>
@@ -9997,7 +10107,7 @@
               </a:defRPr>
             </a:pPr>
             <a:r>
-              <a:t>Key aspect of Implementation Method</a:t>
+              <a:t>Prompt engineering and the critical</a:t>
             </a:r>
           </a:p>
         </p:txBody>
@@ -10077,7 +10187,7 @@
               </a:defRPr>
             </a:pPr>
             <a:r>
-              <a:t>Key aspect of Implementation Method</a:t>
+              <a:t>Performance-resource tradeoffs in m</a:t>
             </a:r>
           </a:p>
         </p:txBody>
@@ -10157,7 +10267,7 @@
               </a:defRPr>
             </a:pPr>
             <a:r>
-              <a:t>While word embeddings serve as proof that textual semantic regularities can be assessed without</a:t>
+              <a:t>Generative AI, particularly large language models, operates on probabilistic foundations, gener</a:t>
             </a:r>
           </a:p>
         </p:txBody>
@@ -10237,7 +10347,7 @@
               </a:defRPr>
             </a:pPr>
             <a:r>
-              <a:t>For example, a common motif in stories is that the next act derives from some event that occurr</a:t>
+              <a:t>The quality and structure of the initial prompt significantly influence the utility and accurac</a:t>
             </a:r>
           </a:p>
         </p:txBody>
@@ -10317,7 +10427,7 @@
               </a:defRPr>
             </a:pPr>
             <a:r>
-              <a:t>Important aspect of Implementation Methods</a:t>
+              <a:t>While LLMs dominate current GenAI applications due to their versatility in language-based tasks</a:t>
             </a:r>
           </a:p>
         </p:txBody>
@@ -10397,7 +10507,7 @@
               </a:defRPr>
             </a:pPr>
             <a:r>
-              <a:t>Important aspect of Implementation Methods</a:t>
+              <a:t>Generative models introduce unique tradeoffs, such as the balance between computational resourc</a:t>
             </a:r>
           </a:p>
         </p:txBody>
@@ -10477,7 +10587,7 @@
               </a:defRPr>
             </a:pPr>
             <a:r>
-              <a:t>Important aspect of Implementation Methods</a:t>
+              <a:t>The probabilistic nature of language models, combined with mechanisms for gathering user feedba</a:t>
             </a:r>
           </a:p>
         </p:txBody>
@@ -10656,7 +10766,7 @@
               </a:defRPr>
             </a:pPr>
             <a:r>
-              <a:t>Advanced Techniques</a:t>
+              <a:t>Language Models Unveiled: Mechanics of Next-Token Prediction and Context Windows</a:t>
             </a:r>
           </a:p>
         </p:txBody>
@@ -10694,7 +10804,7 @@
               </a:defRPr>
             </a:pPr>
             <a:r>
-              <a:t>Advanced implementations and optimizations. While generative AI models come in many different shapes, utilizing varied s</a:t>
+              <a:t>By the end of this study, learners should understand the core mechanics of next-token prediction in large language model</a:t>
             </a:r>
           </a:p>
         </p:txBody>
@@ -10774,7 +10884,7 @@
               </a:defRPr>
             </a:pPr>
             <a:r>
-              <a:t>While generative AI models come in </a:t>
+              <a:t>Next-token prediction as the founda</a:t>
             </a:r>
           </a:p>
         </p:txBody>
@@ -10854,7 +10964,7 @@
               </a:defRPr>
             </a:pPr>
             <a:r>
-              <a:t>We start with the most well-underst</a:t>
+              <a:t>Context windows (or prompts) as the</a:t>
             </a:r>
           </a:p>
         </p:txBody>
@@ -10934,7 +11044,7 @@
               </a:defRPr>
             </a:pPr>
             <a:r>
-              <a:t>Key aspect of Advanced Techniques</a:t>
+              <a:t>In-context learning, a paradigm whe</a:t>
             </a:r>
           </a:p>
         </p:txBody>
@@ -11014,7 +11124,7 @@
               </a:defRPr>
             </a:pPr>
             <a:r>
-              <a:t>While generative AI models come in many different shapes, utilizing varied statistical and comp</a:t>
+              <a:t>Modern language models distinguish themselves from earlier generations by maintaining awareness</a:t>
             </a:r>
           </a:p>
         </p:txBody>
@@ -11094,7 +11204,7 @@
               </a:defRPr>
             </a:pPr>
             <a:r>
-              <a:t>This choice is partly due to the substantial lead LLMs have in driving the overall usage of gen</a:t>
+              <a:t>The primary measure of success for language models is their ability to make reasonable predicti</a:t>
             </a:r>
           </a:p>
         </p:txBody>
@@ -11174,7 +11284,7 @@
               </a:defRPr>
             </a:pPr>
             <a:r>
-              <a:t>That said, image- and code-based GenAI models have already witnessed successful commercial prod</a:t>
+              <a:t>While traditional supervised learning relies on carefully curated datasets tailored to specific</a:t>
             </a:r>
           </a:p>
         </p:txBody>
@@ -11254,7 +11364,7 @@
               </a:defRPr>
             </a:pPr>
             <a:r>
-              <a:t>We start with the most well-understood subset of machine learning techniques: supervised learni</a:t>
+              <a:t>The introduction of in-context learning in models like GPT-3 has revolutionized the practical d</a:t>
             </a:r>
           </a:p>
         </p:txBody>
@@ -11334,7 +11444,7 @@
               </a:defRPr>
             </a:pPr>
             <a:r>
-              <a:t>The central objective in supervised learning is to produce a prediction rule that predicts well</a:t>
+              <a:t>Despite the computational efficiency of in-context learning, fine-tuning may still offer perfor</a:t>
             </a:r>
           </a:p>
         </p:txBody>
@@ -11513,7 +11623,7 @@
               </a:defRPr>
             </a:pPr>
             <a:r>
-              <a:t>Real-World Applications</a:t>
+              <a:t>Stochasticity in GenAI: The Role of Randomness in Generating Diverse and Plausible Outputs</a:t>
             </a:r>
           </a:p>
         </p:txBody>
@@ -11551,7 +11661,7 @@
               </a:defRPr>
             </a:pPr>
             <a:r>
-              <a:t>Case studies and practical examples about Real-World Applications</a:t>
+              <a:t>By studying this material, learners should understand the fundamental role of stochasticity in generative AI, particular</a:t>
             </a:r>
           </a:p>
         </p:txBody>
@@ -11631,7 +11741,7 @@
               </a:defRPr>
             </a:pPr>
             <a:r>
-              <a:t>Karan Singh, Assistant Professor of</a:t>
+              <a:t>Stochasticity in generative AI refe</a:t>
             </a:r>
           </a:p>
         </p:txBody>
@@ -11711,7 +11821,7 @@
               </a:defRPr>
             </a:pPr>
             <a:r>
-              <a:t>Generative artificial intelligence </a:t>
+              <a:t>Prompt engineering is the practice </a:t>
             </a:r>
           </a:p>
         </p:txBody>
@@ -11791,7 +11901,7 @@
               </a:defRPr>
             </a:pPr>
             <a:r>
-              <a:t>This rapid progress has led many to</a:t>
+              <a:t>Beam Search is a systematic search </a:t>
             </a:r>
           </a:p>
         </p:txBody>
@@ -11871,7 +11981,7 @@
               </a:defRPr>
             </a:pPr>
             <a:r>
-              <a:t>Karan Singh, Assistant Professor of Operations Research</a:t>
+              <a:t>The stochastic nature of generative AI models, such as ChatGPT, is what allows them to produce </a:t>
             </a:r>
           </a:p>
         </p:txBody>
@@ -11951,7 +12061,7 @@
               </a:defRPr>
             </a:pPr>
             <a:r>
-              <a:t>Generative artificial intelligence (GenAI) tools are an emerging class of new-age artificial in</a:t>
+              <a:t>Replacing the stochastic sampling step with a greedy, deterministic approach—where the most lik</a:t>
             </a:r>
           </a:p>
         </p:txBody>
@@ -12031,7 +12141,7 @@
               </a:defRPr>
             </a:pPr>
             <a:r>
-              <a:t>Recent advances in machine learning (ML), massive datasets, and substantial increases in comput</a:t>
+              <a:t>Prompt engineering has emerged as a critical skill in leveraging generative AI, as artfully cra</a:t>
             </a:r>
           </a:p>
         </p:txBody>
@@ -12111,7 +12221,7 @@
               </a:defRPr>
             </a:pPr>
             <a:r>
-              <a:t>This rapid progress has led many to to believe that the metamorphosis of these technologies 2fr</a:t>
+              <a:t>While generative AI encompasses a broad range of modalities, including audio, video, and code, </a:t>
             </a:r>
           </a:p>
         </p:txBody>
@@ -12191,7 +12301,7 @@
               </a:defRPr>
             </a:pPr>
             <a:r>
-              <a:t>It took OpenAI's ChatGPT, a conversational web app based on a generative (multimodal) language </a:t>
+              <a:t>Modern language models differ from earlier generations by maintaining awareness of the initial </a:t>
             </a:r>
           </a:p>
         </p:txBody>
@@ -12370,7 +12480,7 @@
               </a:defRPr>
             </a:pPr>
             <a:r>
-              <a:t>Applications Continued</a:t>
+              <a:t>Prompt Engineering: How Initial Context Shapes GenAI Outputs and Applications</a:t>
             </a:r>
           </a:p>
         </p:txBody>
@@ -12408,7 +12518,7 @@
               </a:defRPr>
             </a:pPr>
             <a:r>
-              <a:t>More application examples and use cases about Applications Continued</a:t>
+              <a:t>By studying this material, learners should master how the initial context—known as the prompt—fundamentally shapes the o</a:t>
             </a:r>
           </a:p>
         </p:txBody>
@@ -12488,7 +12598,7 @@
               </a:defRPr>
             </a:pPr>
             <a:r>
-              <a:t>Karan Singh, Assistant Professor of</a:t>
+              <a:t>Prompt Engineering</a:t>
             </a:r>
           </a:p>
         </p:txBody>
@@ -12568,7 +12678,7 @@
               </a:defRPr>
             </a:pPr>
             <a:r>
-              <a:t>Generative artificial intelligence </a:t>
+              <a:t>Beam Search</a:t>
             </a:r>
           </a:p>
         </p:txBody>
@@ -12648,7 +12758,7 @@
               </a:defRPr>
             </a:pPr>
             <a:r>
-              <a:t>This rapid progress has led many to</a:t>
+              <a:t>In-Context Learning</a:t>
             </a:r>
           </a:p>
         </p:txBody>
@@ -12728,7 +12838,7 @@
               </a:defRPr>
             </a:pPr>
             <a:r>
-              <a:t>Karan Singh, Assistant Professor of Operations Research</a:t>
+              <a:t>Prompt engineering refers to the deliberate structuring of initial text inputs to elicit more u</a:t>
             </a:r>
           </a:p>
         </p:txBody>
@@ -12808,7 +12918,7 @@
               </a:defRPr>
             </a:pPr>
             <a:r>
-              <a:t>Generative artificial intelligence (GenAI) tools are an emerging class of new-age artificial in</a:t>
+              <a:t>Unlike earlier models, modern language models maintain awareness of the initial prompt througho</a:t>
             </a:r>
           </a:p>
         </p:txBody>
@@ -12888,7 +12998,7 @@
               </a:defRPr>
             </a:pPr>
             <a:r>
-              <a:t>Recent advances in machine learning (ML), massive datasets, and substantial increases in comput</a:t>
+              <a:t>In-context learning is a method that allows pre-trained language models to adapt to new tasks w</a:t>
             </a:r>
           </a:p>
         </p:txBody>
@@ -12968,7 +13078,7 @@
               </a:defRPr>
             </a:pPr>
             <a:r>
-              <a:t>This rapid progress has led many to to believe that the metamorphosis of these technologies 2fr</a:t>
+              <a:t>Generative AI tools, such as large language models, have achieved human-level performance on be</a:t>
             </a:r>
           </a:p>
         </p:txBody>
@@ -13048,7 +13158,7 @@
               </a:defRPr>
             </a:pPr>
             <a:r>
-              <a:t>It took OpenAI's ChatGPT, a conversational web app based on a generative (multimodal) language </a:t>
+              <a:t>While fine-tuning a model may still offer performance gains for certain tasks, the gap between </a:t>
             </a:r>
           </a:p>
         </p:txBody>

</xml_diff>